<commit_message>
The deck's strongest slide is the one where the project was wrong
Slide 9 listed caveats. The best thing this project produced is not a
caveat - it is a measurement that disproved its own premise, and it now
has its own slide: the same SPY run at 0, 17.00 and the measured 34.95
USD per spread per execution, going +2,850 -> -433 -> -6,172.65.

Cover and deck rebuilt on the current snapshot. 11 slides, 93 tests.

Co-Authored-By: Claude Opus 5 <noreply@anthropic.com>
</commit_message>
<xml_diff>
--- a/docs/deck.pptx
+++ b/docs/deck.pptx
@@ -15,6 +15,7 @@
     <p:sldId id="263" r:id="rId14"/>
     <p:sldId id="264" r:id="rId15"/>
     <p:sldId id="265" r:id="rId16"/>
+    <p:sldId id="266" r:id="rId17"/>
   </p:sldIdLst>
   <p:sldSz cx="12191695" cy="6858000" type="screen4x3"/>
   <p:notesSz cx="6858000" cy="9144000"/>
@@ -3414,7 +3415,7 @@
                 </a:solidFill>
                 <a:latin typeface="Consolas"/>
               </a:rPr>
-              <a:t>89,802</a:t>
+              <a:t>90,195</a:t>
             </a:r>
           </a:p>
         </p:txBody>
@@ -3492,7 +3493,7 @@
                 </a:solidFill>
                 <a:latin typeface="Consolas"/>
               </a:rPr>
-              <a:t>-10,198</a:t>
+              <a:t>-9,805</a:t>
             </a:r>
           </a:p>
         </p:txBody>
@@ -3648,7 +3649,7 @@
                 </a:solidFill>
                 <a:latin typeface="Consolas"/>
               </a:rPr>
-              <a:t>456</a:t>
+              <a:t>506</a:t>
             </a:r>
           </a:p>
         </p:txBody>
@@ -3735,7 +3736,7 @@
                 </a:solidFill>
                 <a:latin typeface="Consolas"/>
               </a:rPr>
-              <a:t>Alpaca AI Trading Agents Hackathon  ·  paper account PA3S85G7JUS0  ·  every figure read back through the Alpaca CLI  ·  as of 2026-09-01 14:03 ET</a:t>
+              <a:t>Alpaca AI Trading Agents Hackathon  ·  paper account PA3S85G7JUS0  ·  every figure read back through the Alpaca CLI  ·  as of 2026-09-01 16:06 ET</a:t>
             </a:r>
           </a:p>
         </p:txBody>
@@ -3802,6 +3803,694 @@
           </a:p>
         </p:txBody>
       </p:sp>
+      <p:sp>
+        <p:nvSpPr>
+          <p:cNvPr id="3" name="TextBox 2"/>
+          <p:cNvSpPr txBox="1"/>
+          <p:nvPr/>
+        </p:nvSpPr>
+        <p:spPr>
+          <a:xfrm>
+            <a:off x="731520" y="502920"/>
+            <a:ext cx="10698480" cy="365760"/>
+          </a:xfrm>
+          <a:prstGeom prst="rect">
+            <a:avLst/>
+          </a:prstGeom>
+          <a:noFill/>
+        </p:spPr>
+        <p:txBody>
+          <a:bodyPr wrap="square">
+            <a:spAutoFit/>
+          </a:bodyPr>
+          <a:lstStyle/>
+          <a:p>
+            <a:pPr algn="l">
+              <a:lnSpc>
+                <a:spcPct val="115000"/>
+              </a:lnSpc>
+            </a:pPr>
+            <a:r>
+              <a:rPr sz="1300" b="1">
+                <a:solidFill>
+                  <a:srgbClr val="8A94A5"/>
+                </a:solidFill>
+                <a:latin typeface="Consolas"/>
+              </a:rPr>
+              <a:t>WHAT IS HONEST ABOUT THIS</a:t>
+            </a:r>
+          </a:p>
+        </p:txBody>
+      </p:sp>
+      <p:sp>
+        <p:nvSpPr>
+          <p:cNvPr id="4" name="TextBox 3"/>
+          <p:cNvSpPr txBox="1"/>
+          <p:nvPr/>
+        </p:nvSpPr>
+        <p:spPr>
+          <a:xfrm>
+            <a:off x="731520" y="868680"/>
+            <a:ext cx="10698480" cy="914400"/>
+          </a:xfrm>
+          <a:prstGeom prst="rect">
+            <a:avLst/>
+          </a:prstGeom>
+          <a:noFill/>
+        </p:spPr>
+        <p:txBody>
+          <a:bodyPr wrap="square">
+            <a:spAutoFit/>
+          </a:bodyPr>
+          <a:lstStyle/>
+          <a:p>
+            <a:pPr algn="l">
+              <a:lnSpc>
+                <a:spcPct val="105000"/>
+              </a:lnSpc>
+            </a:pPr>
+            <a:r>
+              <a:rPr sz="3000" b="1">
+                <a:solidFill>
+                  <a:srgbClr val="E8ECF2"/>
+                </a:solidFill>
+                <a:latin typeface="Georgia"/>
+              </a:rPr>
+              <a:t>The parts that are not finished</a:t>
+            </a:r>
+          </a:p>
+        </p:txBody>
+      </p:sp>
+      <p:sp>
+        <p:nvSpPr>
+          <p:cNvPr id="5" name="Rectangle 4"/>
+          <p:cNvSpPr/>
+          <p:nvPr/>
+        </p:nvSpPr>
+        <p:spPr>
+          <a:xfrm>
+            <a:off x="731520" y="1783080"/>
+            <a:ext cx="10698480" cy="9525"/>
+          </a:xfrm>
+          <a:prstGeom prst="rect">
+            <a:avLst/>
+          </a:prstGeom>
+          <a:solidFill>
+            <a:srgbClr val="242C38"/>
+          </a:solidFill>
+          <a:ln>
+            <a:noFill/>
+          </a:ln>
+          <a:effectLst/>
+        </p:spPr>
+        <p:style>
+          <a:lnRef idx="1">
+            <a:schemeClr val="accent1"/>
+          </a:lnRef>
+          <a:fillRef idx="3">
+            <a:schemeClr val="accent1"/>
+          </a:fillRef>
+          <a:effectRef idx="2">
+            <a:schemeClr val="accent1"/>
+          </a:effectRef>
+          <a:fontRef idx="minor">
+            <a:schemeClr val="lt1"/>
+          </a:fontRef>
+        </p:style>
+        <p:txBody>
+          <a:bodyPr rtlCol="0" anchor="ctr"/>
+          <a:lstStyle/>
+          <a:p>
+            <a:pPr algn="ctr"/>
+          </a:p>
+        </p:txBody>
+      </p:sp>
+      <p:sp>
+        <p:nvSpPr>
+          <p:cNvPr id="6" name="TextBox 5"/>
+          <p:cNvSpPr txBox="1"/>
+          <p:nvPr/>
+        </p:nvSpPr>
+        <p:spPr>
+          <a:xfrm>
+            <a:off x="731520" y="2148840"/>
+            <a:ext cx="10698480" cy="502920"/>
+          </a:xfrm>
+          <a:prstGeom prst="rect">
+            <a:avLst/>
+          </a:prstGeom>
+          <a:noFill/>
+        </p:spPr>
+        <p:txBody>
+          <a:bodyPr wrap="square">
+            <a:spAutoFit/>
+          </a:bodyPr>
+          <a:lstStyle/>
+          <a:p>
+            <a:pPr algn="l">
+              <a:lnSpc>
+                <a:spcPct val="115000"/>
+              </a:lnSpc>
+            </a:pPr>
+            <a:r>
+              <a:rPr sz="1600" b="1">
+                <a:solidFill>
+                  <a:srgbClr val="8AA6EF"/>
+                </a:solidFill>
+                <a:latin typeface="Georgia"/>
+              </a:rPr>
+              <a:t>Untuned.  </a:t>
+            </a:r>
+            <a:r>
+              <a:rPr sz="1600" b="0">
+                <a:solidFill>
+                  <a:srgbClr val="E8ECF2"/>
+                </a:solidFill>
+                <a:latin typeface="Georgia"/>
+              </a:rPr>
+              <a:t>The grid parameters come from the author's cTrader Forex bot. They are not tuned for options, or for a one-week window.</a:t>
+            </a:r>
+          </a:p>
+        </p:txBody>
+      </p:sp>
+      <p:sp>
+        <p:nvSpPr>
+          <p:cNvPr id="7" name="TextBox 6"/>
+          <p:cNvSpPr txBox="1"/>
+          <p:nvPr/>
+        </p:nvSpPr>
+        <p:spPr>
+          <a:xfrm>
+            <a:off x="731520" y="2953512"/>
+            <a:ext cx="10698480" cy="502920"/>
+          </a:xfrm>
+          <a:prstGeom prst="rect">
+            <a:avLst/>
+          </a:prstGeom>
+          <a:noFill/>
+        </p:spPr>
+        <p:txBody>
+          <a:bodyPr wrap="square">
+            <a:spAutoFit/>
+          </a:bodyPr>
+          <a:lstStyle/>
+          <a:p>
+            <a:pPr algn="l">
+              <a:lnSpc>
+                <a:spcPct val="115000"/>
+              </a:lnSpc>
+            </a:pPr>
+            <a:r>
+              <a:rPr sz="1600" b="1">
+                <a:solidFill>
+                  <a:srgbClr val="8AA6EF"/>
+                </a:solidFill>
+                <a:latin typeface="Georgia"/>
+              </a:rPr>
+              <a:t>An unmeasured tail.  </a:t>
+            </a:r>
+            <a:r>
+              <a:rPr sz="1600" b="0">
+                <a:solidFill>
+                  <a:srgbClr val="E8ECF2"/>
+                </a:solidFill>
+                <a:latin typeface="Georgia"/>
+              </a:rPr>
+              <a:t>Alpaca option data begins 2024-02 and holds no sustained bear market. The tail is bounded by construction — every position is a spread — but unmeasured.</a:t>
+            </a:r>
+          </a:p>
+        </p:txBody>
+      </p:sp>
+      <p:sp>
+        <p:nvSpPr>
+          <p:cNvPr id="8" name="TextBox 7"/>
+          <p:cNvSpPr txBox="1"/>
+          <p:nvPr/>
+        </p:nvSpPr>
+        <p:spPr>
+          <a:xfrm>
+            <a:off x="731520" y="3758184"/>
+            <a:ext cx="10698480" cy="502920"/>
+          </a:xfrm>
+          <a:prstGeom prst="rect">
+            <a:avLst/>
+          </a:prstGeom>
+          <a:noFill/>
+        </p:spPr>
+        <p:txBody>
+          <a:bodyPr wrap="square">
+            <a:spAutoFit/>
+          </a:bodyPr>
+          <a:lstStyle/>
+          <a:p>
+            <a:pPr algn="l">
+              <a:lnSpc>
+                <a:spcPct val="115000"/>
+              </a:lnSpc>
+            </a:pPr>
+            <a:r>
+              <a:rPr sz="1600" b="1">
+                <a:solidFill>
+                  <a:srgbClr val="8AA6EF"/>
+                </a:solidFill>
+                <a:latin typeface="Georgia"/>
+              </a:rPr>
+              <a:t>A martingale, deliberately.  </a:t>
+            </a:r>
+            <a:r>
+              <a:rPr sz="1600" b="0">
+                <a:solidFill>
+                  <a:srgbClr val="E8ECF2"/>
+                </a:solidFill>
+                <a:latin typeface="Georgia"/>
+              </a:rPr>
+              <a:t>It adds into a losing position. That is the strategy, not a defect, and the drawdown on this page is what it looks like.</a:t>
+            </a:r>
+          </a:p>
+        </p:txBody>
+      </p:sp>
+      <p:sp>
+        <p:nvSpPr>
+          <p:cNvPr id="9" name="TextBox 8"/>
+          <p:cNvSpPr txBox="1"/>
+          <p:nvPr/>
+        </p:nvSpPr>
+        <p:spPr>
+          <a:xfrm>
+            <a:off x="731520" y="4562856"/>
+            <a:ext cx="10698480" cy="502920"/>
+          </a:xfrm>
+          <a:prstGeom prst="rect">
+            <a:avLst/>
+          </a:prstGeom>
+          <a:noFill/>
+        </p:spPr>
+        <p:txBody>
+          <a:bodyPr wrap="square">
+            <a:spAutoFit/>
+          </a:bodyPr>
+          <a:lstStyle/>
+          <a:p>
+            <a:pPr algn="l">
+              <a:lnSpc>
+                <a:spcPct val="115000"/>
+              </a:lnSpc>
+            </a:pPr>
+            <a:r>
+              <a:rPr sz="1600" b="1">
+                <a:solidFill>
+                  <a:srgbClr val="8AA6EF"/>
+                </a:solidFill>
+                <a:latin typeface="Georgia"/>
+              </a:rPr>
+              <a:t>The AI sizes only.  </a:t>
+            </a:r>
+            <a:r>
+              <a:rPr sz="1600" b="0">
+                <a:solidFill>
+                  <a:srgbClr val="E8ECF2"/>
+                </a:solidFill>
+                <a:latin typeface="Georgia"/>
+              </a:rPr>
+              <a:t>Underlying choice and DTE/strike policy are still rules, not judgements.</a:t>
+            </a:r>
+          </a:p>
+        </p:txBody>
+      </p:sp>
+      <p:sp>
+        <p:nvSpPr>
+          <p:cNvPr id="10" name="TextBox 9"/>
+          <p:cNvSpPr txBox="1"/>
+          <p:nvPr/>
+        </p:nvSpPr>
+        <p:spPr>
+          <a:xfrm>
+            <a:off x="731520" y="5486400"/>
+            <a:ext cx="2674620" cy="274320"/>
+          </a:xfrm>
+          <a:prstGeom prst="rect">
+            <a:avLst/>
+          </a:prstGeom>
+          <a:noFill/>
+        </p:spPr>
+        <p:txBody>
+          <a:bodyPr wrap="square">
+            <a:spAutoFit/>
+          </a:bodyPr>
+          <a:lstStyle/>
+          <a:p>
+            <a:pPr algn="l">
+              <a:lnSpc>
+                <a:spcPct val="115000"/>
+              </a:lnSpc>
+            </a:pPr>
+            <a:r>
+              <a:rPr sz="1100" b="1">
+                <a:solidFill>
+                  <a:srgbClr val="8A94A5"/>
+                </a:solidFill>
+                <a:latin typeface="Consolas"/>
+              </a:rPr>
+              <a:t>EQUITY</a:t>
+            </a:r>
+          </a:p>
+        </p:txBody>
+      </p:sp>
+      <p:sp>
+        <p:nvSpPr>
+          <p:cNvPr id="11" name="TextBox 10"/>
+          <p:cNvSpPr txBox="1"/>
+          <p:nvPr/>
+        </p:nvSpPr>
+        <p:spPr>
+          <a:xfrm>
+            <a:off x="731520" y="5742432"/>
+            <a:ext cx="2674620" cy="548640"/>
+          </a:xfrm>
+          <a:prstGeom prst="rect">
+            <a:avLst/>
+          </a:prstGeom>
+          <a:noFill/>
+        </p:spPr>
+        <p:txBody>
+          <a:bodyPr wrap="square">
+            <a:spAutoFit/>
+          </a:bodyPr>
+          <a:lstStyle/>
+          <a:p>
+            <a:pPr algn="l">
+              <a:lnSpc>
+                <a:spcPct val="115000"/>
+              </a:lnSpc>
+            </a:pPr>
+            <a:r>
+              <a:rPr sz="2200" b="1">
+                <a:solidFill>
+                  <a:srgbClr val="E8ECF2"/>
+                </a:solidFill>
+                <a:latin typeface="Consolas"/>
+              </a:rPr>
+              <a:t>90,195</a:t>
+            </a:r>
+          </a:p>
+        </p:txBody>
+      </p:sp>
+      <p:sp>
+        <p:nvSpPr>
+          <p:cNvPr id="12" name="TextBox 11"/>
+          <p:cNvSpPr txBox="1"/>
+          <p:nvPr/>
+        </p:nvSpPr>
+        <p:spPr>
+          <a:xfrm>
+            <a:off x="3406139" y="5486400"/>
+            <a:ext cx="2674620" cy="274320"/>
+          </a:xfrm>
+          <a:prstGeom prst="rect">
+            <a:avLst/>
+          </a:prstGeom>
+          <a:noFill/>
+        </p:spPr>
+        <p:txBody>
+          <a:bodyPr wrap="square">
+            <a:spAutoFit/>
+          </a:bodyPr>
+          <a:lstStyle/>
+          <a:p>
+            <a:pPr algn="l">
+              <a:lnSpc>
+                <a:spcPct val="115000"/>
+              </a:lnSpc>
+            </a:pPr>
+            <a:r>
+              <a:rPr sz="1100" b="1">
+                <a:solidFill>
+                  <a:srgbClr val="8A94A5"/>
+                </a:solidFill>
+                <a:latin typeface="Consolas"/>
+              </a:rPr>
+              <a:t>P&amp;L</a:t>
+            </a:r>
+          </a:p>
+        </p:txBody>
+      </p:sp>
+      <p:sp>
+        <p:nvSpPr>
+          <p:cNvPr id="13" name="TextBox 12"/>
+          <p:cNvSpPr txBox="1"/>
+          <p:nvPr/>
+        </p:nvSpPr>
+        <p:spPr>
+          <a:xfrm>
+            <a:off x="3406139" y="5742432"/>
+            <a:ext cx="2674620" cy="548640"/>
+          </a:xfrm>
+          <a:prstGeom prst="rect">
+            <a:avLst/>
+          </a:prstGeom>
+          <a:noFill/>
+        </p:spPr>
+        <p:txBody>
+          <a:bodyPr wrap="square">
+            <a:spAutoFit/>
+          </a:bodyPr>
+          <a:lstStyle/>
+          <a:p>
+            <a:pPr algn="l">
+              <a:lnSpc>
+                <a:spcPct val="115000"/>
+              </a:lnSpc>
+            </a:pPr>
+            <a:r>
+              <a:rPr sz="2200" b="1">
+                <a:solidFill>
+                  <a:srgbClr val="E06A4E"/>
+                </a:solidFill>
+                <a:latin typeface="Consolas"/>
+              </a:rPr>
+              <a:t>-9,805  (-9.81 %)</a:t>
+            </a:r>
+          </a:p>
+        </p:txBody>
+      </p:sp>
+      <p:sp>
+        <p:nvSpPr>
+          <p:cNvPr id="14" name="TextBox 13"/>
+          <p:cNvSpPr txBox="1"/>
+          <p:nvPr/>
+        </p:nvSpPr>
+        <p:spPr>
+          <a:xfrm>
+            <a:off x="6080759" y="5486400"/>
+            <a:ext cx="2674620" cy="274320"/>
+          </a:xfrm>
+          <a:prstGeom prst="rect">
+            <a:avLst/>
+          </a:prstGeom>
+          <a:noFill/>
+        </p:spPr>
+        <p:txBody>
+          <a:bodyPr wrap="square">
+            <a:spAutoFit/>
+          </a:bodyPr>
+          <a:lstStyle/>
+          <a:p>
+            <a:pPr algn="l">
+              <a:lnSpc>
+                <a:spcPct val="115000"/>
+              </a:lnSpc>
+            </a:pPr>
+            <a:r>
+              <a:rPr sz="1100" b="1">
+                <a:solidFill>
+                  <a:srgbClr val="8A94A5"/>
+                </a:solidFill>
+                <a:latin typeface="Consolas"/>
+              </a:rPr>
+              <a:t>OPEN SPREADS</a:t>
+            </a:r>
+          </a:p>
+        </p:txBody>
+      </p:sp>
+      <p:sp>
+        <p:nvSpPr>
+          <p:cNvPr id="15" name="TextBox 14"/>
+          <p:cNvSpPr txBox="1"/>
+          <p:nvPr/>
+        </p:nvSpPr>
+        <p:spPr>
+          <a:xfrm>
+            <a:off x="6080759" y="5742432"/>
+            <a:ext cx="2674620" cy="548640"/>
+          </a:xfrm>
+          <a:prstGeom prst="rect">
+            <a:avLst/>
+          </a:prstGeom>
+          <a:noFill/>
+        </p:spPr>
+        <p:txBody>
+          <a:bodyPr wrap="square">
+            <a:spAutoFit/>
+          </a:bodyPr>
+          <a:lstStyle/>
+          <a:p>
+            <a:pPr algn="l">
+              <a:lnSpc>
+                <a:spcPct val="115000"/>
+              </a:lnSpc>
+            </a:pPr>
+            <a:r>
+              <a:rPr sz="2200" b="1">
+                <a:solidFill>
+                  <a:srgbClr val="E8ECF2"/>
+                </a:solidFill>
+                <a:latin typeface="Consolas"/>
+              </a:rPr>
+              <a:t>51</a:t>
+            </a:r>
+          </a:p>
+        </p:txBody>
+      </p:sp>
+      <p:sp>
+        <p:nvSpPr>
+          <p:cNvPr id="16" name="TextBox 15"/>
+          <p:cNvSpPr txBox="1"/>
+          <p:nvPr/>
+        </p:nvSpPr>
+        <p:spPr>
+          <a:xfrm>
+            <a:off x="8755380" y="5486400"/>
+            <a:ext cx="2674620" cy="274320"/>
+          </a:xfrm>
+          <a:prstGeom prst="rect">
+            <a:avLst/>
+          </a:prstGeom>
+          <a:noFill/>
+        </p:spPr>
+        <p:txBody>
+          <a:bodyPr wrap="square">
+            <a:spAutoFit/>
+          </a:bodyPr>
+          <a:lstStyle/>
+          <a:p>
+            <a:pPr algn="l">
+              <a:lnSpc>
+                <a:spcPct val="115000"/>
+              </a:lnSpc>
+            </a:pPr>
+            <a:r>
+              <a:rPr sz="1100" b="1">
+                <a:solidFill>
+                  <a:srgbClr val="8A94A5"/>
+                </a:solidFill>
+                <a:latin typeface="Consolas"/>
+              </a:rPr>
+              <a:t>RESIDUAL</a:t>
+            </a:r>
+          </a:p>
+        </p:txBody>
+      </p:sp>
+      <p:sp>
+        <p:nvSpPr>
+          <p:cNvPr id="17" name="TextBox 16"/>
+          <p:cNvSpPr txBox="1"/>
+          <p:nvPr/>
+        </p:nvSpPr>
+        <p:spPr>
+          <a:xfrm>
+            <a:off x="8755380" y="5742432"/>
+            <a:ext cx="2674620" cy="548640"/>
+          </a:xfrm>
+          <a:prstGeom prst="rect">
+            <a:avLst/>
+          </a:prstGeom>
+          <a:noFill/>
+        </p:spPr>
+        <p:txBody>
+          <a:bodyPr wrap="square">
+            <a:spAutoFit/>
+          </a:bodyPr>
+          <a:lstStyle/>
+          <a:p>
+            <a:pPr algn="l">
+              <a:lnSpc>
+                <a:spcPct val="115000"/>
+              </a:lnSpc>
+            </a:pPr>
+            <a:r>
+              <a:rPr sz="2200" b="1">
+                <a:solidFill>
+                  <a:srgbClr val="8AA6EF"/>
+                </a:solidFill>
+                <a:latin typeface="Consolas"/>
+              </a:rPr>
+              <a:t>+0.0000</a:t>
+            </a:r>
+          </a:p>
+        </p:txBody>
+      </p:sp>
+    </p:spTree>
+  </p:cSld>
+  <p:clrMapOvr>
+    <a:masterClrMapping/>
+  </p:clrMapOvr>
+</p:sld>
+</file>
+
+<file path=ppt/slides/slide11.xml><?xml version="1.0" encoding="utf-8"?>
+<p:sld xmlns:a="http://schemas.openxmlformats.org/drawingml/2006/main" xmlns:p="http://schemas.openxmlformats.org/presentationml/2006/main" xmlns:r="http://schemas.openxmlformats.org/officeDocument/2006/relationships">
+  <p:cSld>
+    <p:spTree>
+      <p:nvGrpSpPr>
+        <p:cNvPr id="1" name=""/>
+        <p:cNvGrpSpPr/>
+        <p:nvPr/>
+      </p:nvGrpSpPr>
+      <p:grpSpPr/>
+      <p:sp>
+        <p:nvSpPr>
+          <p:cNvPr id="2" name="Rectangle 1"/>
+          <p:cNvSpPr/>
+          <p:nvPr/>
+        </p:nvSpPr>
+        <p:spPr>
+          <a:xfrm>
+            <a:off x="0" y="0"/>
+            <a:ext cx="12191695" cy="6858000"/>
+          </a:xfrm>
+          <a:prstGeom prst="rect">
+            <a:avLst/>
+          </a:prstGeom>
+          <a:solidFill>
+            <a:srgbClr val="0C0F14"/>
+          </a:solidFill>
+          <a:ln>
+            <a:noFill/>
+          </a:ln>
+          <a:effectLst/>
+        </p:spPr>
+        <p:style>
+          <a:lnRef idx="1">
+            <a:schemeClr val="accent1"/>
+          </a:lnRef>
+          <a:fillRef idx="3">
+            <a:schemeClr val="accent1"/>
+          </a:fillRef>
+          <a:effectRef idx="2">
+            <a:schemeClr val="accent1"/>
+          </a:effectRef>
+          <a:fontRef idx="minor">
+            <a:schemeClr val="lt1"/>
+          </a:fontRef>
+        </p:style>
+        <p:txBody>
+          <a:bodyPr rtlCol="0" anchor="ctr"/>
+          <a:lstStyle/>
+          <a:p>
+            <a:pPr algn="ctr"/>
+          </a:p>
+        </p:txBody>
+      </p:sp>
       <p:pic>
         <p:nvPicPr>
           <p:cNvPr id="3" name="Picture 2" descr="cover.png"/>
@@ -6408,7 +7097,7 @@
                 </a:solidFill>
                 <a:latin typeface="Consolas"/>
               </a:rPr>
-              <a:t>   89,801.93 - 100,000   =  +1,889.00 -12,067.00 - 15.12 - 4.95</a:t>
+              <a:t>   90,194.58 - 100,000   =  +2,168.00 -11,952.00 - 15.12 - 6.30</a:t>
             </a:r>
           </a:p>
           <a:p>
@@ -7020,7 +7709,7 @@
                 </a:solidFill>
                 <a:latin typeface="Georgia"/>
               </a:rPr>
-              <a:t>built from the account data behind it. 90 tests.</a:t>
+              <a:t>built from the account data behind it. 93 tests.</a:t>
             </a:r>
           </a:p>
         </p:txBody>
@@ -7169,7 +7858,7 @@
                 </a:solidFill>
                 <a:latin typeface="Consolas"/>
               </a:rPr>
-              <a:t>WHAT IS HONEST ABOUT THIS</a:t>
+              <a:t>WHAT THE MEASURING FOUND</a:t>
             </a:r>
           </a:p>
         </p:txBody>
@@ -7208,7 +7897,7 @@
                 </a:solidFill>
                 <a:latin typeface="Georgia"/>
               </a:rPr>
-              <a:t>The parts that are not finished</a:t>
+              <a:t>The backtest never paid the bid/ask</a:t>
             </a:r>
           </a:p>
         </p:txBody>
@@ -7259,14 +7948,60 @@
       </p:sp>
       <p:sp>
         <p:nvSpPr>
-          <p:cNvPr id="6" name="TextBox 5"/>
+          <p:cNvPr id="6" name="Rectangle 5"/>
+          <p:cNvSpPr/>
+          <p:nvPr/>
+        </p:nvSpPr>
+        <p:spPr>
+          <a:xfrm>
+            <a:off x="731520" y="2148840"/>
+            <a:ext cx="10698480" cy="1857756"/>
+          </a:xfrm>
+          <a:prstGeom prst="rect">
+            <a:avLst/>
+          </a:prstGeom>
+          <a:solidFill>
+            <a:srgbClr val="141922"/>
+          </a:solidFill>
+          <a:ln>
+            <a:solidFill>
+              <a:srgbClr val="242C38"/>
+            </a:solidFill>
+          </a:ln>
+          <a:effectLst/>
+        </p:spPr>
+        <p:style>
+          <a:lnRef idx="1">
+            <a:schemeClr val="accent1"/>
+          </a:lnRef>
+          <a:fillRef idx="3">
+            <a:schemeClr val="accent1"/>
+          </a:fillRef>
+          <a:effectRef idx="2">
+            <a:schemeClr val="accent1"/>
+          </a:effectRef>
+          <a:fontRef idx="minor">
+            <a:schemeClr val="lt1"/>
+          </a:fontRef>
+        </p:style>
+        <p:txBody>
+          <a:bodyPr rtlCol="0" anchor="ctr"/>
+          <a:lstStyle/>
+          <a:p>
+            <a:pPr algn="ctr"/>
+          </a:p>
+        </p:txBody>
+      </p:sp>
+      <p:sp>
+        <p:nvSpPr>
+          <p:cNvPr id="7" name="TextBox 6"/>
           <p:cNvSpPr txBox="1"/>
           <p:nvPr/>
         </p:nvSpPr>
         <p:spPr>
           <a:xfrm>
-            <a:off x="731520" y="2148840"/>
-            <a:ext cx="10698480" cy="502920"/>
+            <a:off x="914400" y="2258568"/>
+            <a:ext cx="10332720" cy="1857756"/>
           </a:xfrm>
           <a:prstGeom prst="rect">
             <a:avLst/>
@@ -7279,41 +8014,112 @@
           </a:bodyPr>
           <a:lstStyle/>
           <a:p>
-            <a:pPr algn="l">
-              <a:lnSpc>
-                <a:spcPct val="115000"/>
-              </a:lnSpc>
-            </a:pPr>
-            <a:r>
-              <a:rPr sz="1600" b="1">
-                <a:solidFill>
-                  <a:srgbClr val="8AA6EF"/>
-                </a:solidFill>
-                <a:latin typeface="Georgia"/>
-              </a:rPr>
-              <a:t>Untuned.  </a:t>
-            </a:r>
-            <a:r>
-              <a:rPr sz="1600" b="0">
+            <a:pPr>
+              <a:lnSpc>
+                <a:spcPct val="125000"/>
+              </a:lnSpc>
+            </a:pPr>
+            <a:r>
+              <a:rPr sz="1400">
                 <a:solidFill>
                   <a:srgbClr val="E8ECF2"/>
                 </a:solidFill>
-                <a:latin typeface="Georgia"/>
-              </a:rPr>
-              <a:t>The grid parameters come from the author's cTrader Forex bot. They are not tuned for options, or for a one-week window.</a:t>
-            </a:r>
-          </a:p>
-        </p:txBody>
-      </p:sp>
-      <p:sp>
-        <p:nvSpPr>
-          <p:cNvPr id="7" name="TextBox 6"/>
+                <a:latin typeface="Consolas"/>
+              </a:rPr>
+              <a:t>SPY put grid, 2024-02..2026-08, one parameter changed:</a:t>
+            </a:r>
+          </a:p>
+          <a:p>
+            <a:pPr>
+              <a:lnSpc>
+                <a:spcPct val="125000"/>
+              </a:lnSpc>
+            </a:pPr>
+            <a:r>
+              <a:rPr sz="1400">
+                <a:solidFill>
+                  <a:srgbClr val="E8ECF2"/>
+                </a:solidFill>
+                <a:latin typeface="Consolas"/>
+              </a:rPr>
+              <a:t/>
+            </a:r>
+          </a:p>
+          <a:p>
+            <a:pPr>
+              <a:lnSpc>
+                <a:spcPct val="125000"/>
+              </a:lnSpc>
+            </a:pPr>
+            <a:r>
+              <a:rPr sz="1400">
+                <a:solidFill>
+                  <a:srgbClr val="E8ECF2"/>
+                </a:solidFill>
+                <a:latin typeface="Consolas"/>
+              </a:rPr>
+              <a:t>   cost per spread per execution      realized      drawdown</a:t>
+            </a:r>
+          </a:p>
+          <a:p>
+            <a:pPr>
+              <a:lnSpc>
+                <a:spcPct val="125000"/>
+              </a:lnSpc>
+            </a:pPr>
+            <a:r>
+              <a:rPr sz="1400">
+                <a:solidFill>
+                  <a:srgbClr val="E8ECF2"/>
+                </a:solidFill>
+                <a:latin typeface="Consolas"/>
+              </a:rPr>
+              <a:t>   0     &lt;- every published run       +2,850.00        -2,994</a:t>
+            </a:r>
+          </a:p>
+          <a:p>
+            <a:pPr>
+              <a:lnSpc>
+                <a:spcPct val="125000"/>
+              </a:lnSpc>
+            </a:pPr>
+            <a:r>
+              <a:rPr sz="1400">
+                <a:solidFill>
+                  <a:srgbClr val="E8ECF2"/>
+                </a:solidFill>
+                <a:latin typeface="Consolas"/>
+              </a:rPr>
+              <a:t>   17.00    median-based                -433.00        -3,716</a:t>
+            </a:r>
+          </a:p>
+          <a:p>
+            <a:pPr>
+              <a:lnSpc>
+                <a:spcPct val="125000"/>
+              </a:lnSpc>
+            </a:pPr>
+            <a:r>
+              <a:rPr sz="1400">
+                <a:solidFill>
+                  <a:srgbClr val="E8ECF2"/>
+                </a:solidFill>
+                <a:latin typeface="Consolas"/>
+              </a:rPr>
+              <a:t>   34.95    MEASURED on the live book -6,172.65        -7,024</a:t>
+            </a:r>
+          </a:p>
+        </p:txBody>
+      </p:sp>
+      <p:sp>
+        <p:nvSpPr>
+          <p:cNvPr id="8" name="TextBox 7"/>
           <p:cNvSpPr txBox="1"/>
           <p:nvPr/>
         </p:nvSpPr>
         <p:spPr>
           <a:xfrm>
-            <a:off x="731520" y="2953512"/>
+            <a:off x="731520" y="4160520"/>
             <a:ext cx="10698480" cy="502920"/>
           </a:xfrm>
           <a:prstGeom prst="rect">
@@ -7339,7 +8145,7 @@
                 </a:solidFill>
                 <a:latin typeface="Georgia"/>
               </a:rPr>
-              <a:t>An unmeasured tail.  </a:t>
+              <a:t>34.95 USD  </a:t>
             </a:r>
             <a:r>
               <a:rPr sz="1600" b="0">
@@ -7348,20 +8154,20 @@
                 </a:solidFill>
                 <a:latin typeface="Georgia"/>
               </a:rPr>
-              <a:t>Alpaca option data begins 2024-02 and holds no sustained bear market. The tail is bounded by construction — every position is a spread — but unmeasured.</a:t>
-            </a:r>
-          </a:p>
-        </p:txBody>
-      </p:sp>
-      <p:sp>
-        <p:nvSpPr>
-          <p:cNvPr id="8" name="TextBox 7"/>
+              <a:t>is half the bid/ask per spread, measured across 188 open legs. 69.89 round trip. Median quote width 4.9 % of mid.</a:t>
+            </a:r>
+          </a:p>
+        </p:txBody>
+      </p:sp>
+      <p:sp>
+        <p:nvSpPr>
+          <p:cNvPr id="9" name="TextBox 8"/>
           <p:cNvSpPr txBox="1"/>
           <p:nvPr/>
         </p:nvSpPr>
         <p:spPr>
           <a:xfrm>
-            <a:off x="731520" y="3758184"/>
+            <a:off x="731520" y="4818888"/>
             <a:ext cx="10698480" cy="502920"/>
           </a:xfrm>
           <a:prstGeom prst="rect">
@@ -7387,7 +8193,7 @@
                 </a:solidFill>
                 <a:latin typeface="Georgia"/>
               </a:rPr>
-              <a:t>A martingale, deliberately.  </a:t>
+              <a:t>The whole published profit  </a:t>
             </a:r>
             <a:r>
               <a:rPr sz="1600" b="0">
@@ -7396,20 +8202,20 @@
                 </a:solidFill>
                 <a:latin typeface="Georgia"/>
               </a:rPr>
-              <a:t>It adds into a losing position. That is the strategy, not a defect, and the drawdown on this page is what it looks like.</a:t>
-            </a:r>
-          </a:p>
-        </p:txBody>
-      </p:sp>
-      <p:sp>
-        <p:nvSpPr>
-          <p:cNvPr id="9" name="TextBox 8"/>
+              <a:t>was smaller than the cost that was never charged. cost_usd now has no default anywhere — every tool refuses to start without it.</a:t>
+            </a:r>
+          </a:p>
+        </p:txBody>
+      </p:sp>
+      <p:sp>
+        <p:nvSpPr>
+          <p:cNvPr id="10" name="TextBox 9"/>
           <p:cNvSpPr txBox="1"/>
           <p:nvPr/>
         </p:nvSpPr>
         <p:spPr>
           <a:xfrm>
-            <a:off x="731520" y="4562856"/>
+            <a:off x="731520" y="5477256"/>
             <a:ext cx="10698480" cy="502920"/>
           </a:xfrm>
           <a:prstGeom prst="rect">
@@ -7435,7 +8241,7 @@
                 </a:solidFill>
                 <a:latin typeface="Georgia"/>
               </a:rPr>
-              <a:t>The AI sizes only.  </a:t>
+              <a:t>And two fixes I proposed  </a:t>
             </a:r>
             <a:r>
               <a:rPr sz="1600" b="0">
@@ -7444,319 +8250,7 @@
                 </a:solidFill>
                 <a:latin typeface="Georgia"/>
               </a:rPr>
-              <a:t>Underlying choice and DTE/strike policy are still rules, not judgements.</a:t>
-            </a:r>
-          </a:p>
-        </p:txBody>
-      </p:sp>
-      <p:sp>
-        <p:nvSpPr>
-          <p:cNvPr id="10" name="TextBox 9"/>
-          <p:cNvSpPr txBox="1"/>
-          <p:nvPr/>
-        </p:nvSpPr>
-        <p:spPr>
-          <a:xfrm>
-            <a:off x="731520" y="5486400"/>
-            <a:ext cx="2674620" cy="274320"/>
-          </a:xfrm>
-          <a:prstGeom prst="rect">
-            <a:avLst/>
-          </a:prstGeom>
-          <a:noFill/>
-        </p:spPr>
-        <p:txBody>
-          <a:bodyPr wrap="square">
-            <a:spAutoFit/>
-          </a:bodyPr>
-          <a:lstStyle/>
-          <a:p>
-            <a:pPr algn="l">
-              <a:lnSpc>
-                <a:spcPct val="115000"/>
-              </a:lnSpc>
-            </a:pPr>
-            <a:r>
-              <a:rPr sz="1100" b="1">
-                <a:solidFill>
-                  <a:srgbClr val="8A94A5"/>
-                </a:solidFill>
-                <a:latin typeface="Consolas"/>
-              </a:rPr>
-              <a:t>EQUITY</a:t>
-            </a:r>
-          </a:p>
-        </p:txBody>
-      </p:sp>
-      <p:sp>
-        <p:nvSpPr>
-          <p:cNvPr id="11" name="TextBox 10"/>
-          <p:cNvSpPr txBox="1"/>
-          <p:nvPr/>
-        </p:nvSpPr>
-        <p:spPr>
-          <a:xfrm>
-            <a:off x="731520" y="5742432"/>
-            <a:ext cx="2674620" cy="548640"/>
-          </a:xfrm>
-          <a:prstGeom prst="rect">
-            <a:avLst/>
-          </a:prstGeom>
-          <a:noFill/>
-        </p:spPr>
-        <p:txBody>
-          <a:bodyPr wrap="square">
-            <a:spAutoFit/>
-          </a:bodyPr>
-          <a:lstStyle/>
-          <a:p>
-            <a:pPr algn="l">
-              <a:lnSpc>
-                <a:spcPct val="115000"/>
-              </a:lnSpc>
-            </a:pPr>
-            <a:r>
-              <a:rPr sz="2200" b="1">
-                <a:solidFill>
-                  <a:srgbClr val="E8ECF2"/>
-                </a:solidFill>
-                <a:latin typeface="Consolas"/>
-              </a:rPr>
-              <a:t>89,802</a:t>
-            </a:r>
-          </a:p>
-        </p:txBody>
-      </p:sp>
-      <p:sp>
-        <p:nvSpPr>
-          <p:cNvPr id="12" name="TextBox 11"/>
-          <p:cNvSpPr txBox="1"/>
-          <p:nvPr/>
-        </p:nvSpPr>
-        <p:spPr>
-          <a:xfrm>
-            <a:off x="3406139" y="5486400"/>
-            <a:ext cx="2674620" cy="274320"/>
-          </a:xfrm>
-          <a:prstGeom prst="rect">
-            <a:avLst/>
-          </a:prstGeom>
-          <a:noFill/>
-        </p:spPr>
-        <p:txBody>
-          <a:bodyPr wrap="square">
-            <a:spAutoFit/>
-          </a:bodyPr>
-          <a:lstStyle/>
-          <a:p>
-            <a:pPr algn="l">
-              <a:lnSpc>
-                <a:spcPct val="115000"/>
-              </a:lnSpc>
-            </a:pPr>
-            <a:r>
-              <a:rPr sz="1100" b="1">
-                <a:solidFill>
-                  <a:srgbClr val="8A94A5"/>
-                </a:solidFill>
-                <a:latin typeface="Consolas"/>
-              </a:rPr>
-              <a:t>P&amp;L</a:t>
-            </a:r>
-          </a:p>
-        </p:txBody>
-      </p:sp>
-      <p:sp>
-        <p:nvSpPr>
-          <p:cNvPr id="13" name="TextBox 12"/>
-          <p:cNvSpPr txBox="1"/>
-          <p:nvPr/>
-        </p:nvSpPr>
-        <p:spPr>
-          <a:xfrm>
-            <a:off x="3406139" y="5742432"/>
-            <a:ext cx="2674620" cy="548640"/>
-          </a:xfrm>
-          <a:prstGeom prst="rect">
-            <a:avLst/>
-          </a:prstGeom>
-          <a:noFill/>
-        </p:spPr>
-        <p:txBody>
-          <a:bodyPr wrap="square">
-            <a:spAutoFit/>
-          </a:bodyPr>
-          <a:lstStyle/>
-          <a:p>
-            <a:pPr algn="l">
-              <a:lnSpc>
-                <a:spcPct val="115000"/>
-              </a:lnSpc>
-            </a:pPr>
-            <a:r>
-              <a:rPr sz="2200" b="1">
-                <a:solidFill>
-                  <a:srgbClr val="E06A4E"/>
-                </a:solidFill>
-                <a:latin typeface="Consolas"/>
-              </a:rPr>
-              <a:t>-10,198  (-10.20 %)</a:t>
-            </a:r>
-          </a:p>
-        </p:txBody>
-      </p:sp>
-      <p:sp>
-        <p:nvSpPr>
-          <p:cNvPr id="14" name="TextBox 13"/>
-          <p:cNvSpPr txBox="1"/>
-          <p:nvPr/>
-        </p:nvSpPr>
-        <p:spPr>
-          <a:xfrm>
-            <a:off x="6080759" y="5486400"/>
-            <a:ext cx="2674620" cy="274320"/>
-          </a:xfrm>
-          <a:prstGeom prst="rect">
-            <a:avLst/>
-          </a:prstGeom>
-          <a:noFill/>
-        </p:spPr>
-        <p:txBody>
-          <a:bodyPr wrap="square">
-            <a:spAutoFit/>
-          </a:bodyPr>
-          <a:lstStyle/>
-          <a:p>
-            <a:pPr algn="l">
-              <a:lnSpc>
-                <a:spcPct val="115000"/>
-              </a:lnSpc>
-            </a:pPr>
-            <a:r>
-              <a:rPr sz="1100" b="1">
-                <a:solidFill>
-                  <a:srgbClr val="8A94A5"/>
-                </a:solidFill>
-                <a:latin typeface="Consolas"/>
-              </a:rPr>
-              <a:t>OPEN SPREADS</a:t>
-            </a:r>
-          </a:p>
-        </p:txBody>
-      </p:sp>
-      <p:sp>
-        <p:nvSpPr>
-          <p:cNvPr id="15" name="TextBox 14"/>
-          <p:cNvSpPr txBox="1"/>
-          <p:nvPr/>
-        </p:nvSpPr>
-        <p:spPr>
-          <a:xfrm>
-            <a:off x="6080759" y="5742432"/>
-            <a:ext cx="2674620" cy="548640"/>
-          </a:xfrm>
-          <a:prstGeom prst="rect">
-            <a:avLst/>
-          </a:prstGeom>
-          <a:noFill/>
-        </p:spPr>
-        <p:txBody>
-          <a:bodyPr wrap="square">
-            <a:spAutoFit/>
-          </a:bodyPr>
-          <a:lstStyle/>
-          <a:p>
-            <a:pPr algn="l">
-              <a:lnSpc>
-                <a:spcPct val="115000"/>
-              </a:lnSpc>
-            </a:pPr>
-            <a:r>
-              <a:rPr sz="2200" b="1">
-                <a:solidFill>
-                  <a:srgbClr val="E8ECF2"/>
-                </a:solidFill>
-                <a:latin typeface="Consolas"/>
-              </a:rPr>
-              <a:t>51</a:t>
-            </a:r>
-          </a:p>
-        </p:txBody>
-      </p:sp>
-      <p:sp>
-        <p:nvSpPr>
-          <p:cNvPr id="16" name="TextBox 15"/>
-          <p:cNvSpPr txBox="1"/>
-          <p:nvPr/>
-        </p:nvSpPr>
-        <p:spPr>
-          <a:xfrm>
-            <a:off x="8755380" y="5486400"/>
-            <a:ext cx="2674620" cy="274320"/>
-          </a:xfrm>
-          <a:prstGeom prst="rect">
-            <a:avLst/>
-          </a:prstGeom>
-          <a:noFill/>
-        </p:spPr>
-        <p:txBody>
-          <a:bodyPr wrap="square">
-            <a:spAutoFit/>
-          </a:bodyPr>
-          <a:lstStyle/>
-          <a:p>
-            <a:pPr algn="l">
-              <a:lnSpc>
-                <a:spcPct val="115000"/>
-              </a:lnSpc>
-            </a:pPr>
-            <a:r>
-              <a:rPr sz="1100" b="1">
-                <a:solidFill>
-                  <a:srgbClr val="8A94A5"/>
-                </a:solidFill>
-                <a:latin typeface="Consolas"/>
-              </a:rPr>
-              <a:t>RESIDUAL</a:t>
-            </a:r>
-          </a:p>
-        </p:txBody>
-      </p:sp>
-      <p:sp>
-        <p:nvSpPr>
-          <p:cNvPr id="17" name="TextBox 16"/>
-          <p:cNvSpPr txBox="1"/>
-          <p:nvPr/>
-        </p:nvSpPr>
-        <p:spPr>
-          <a:xfrm>
-            <a:off x="8755380" y="5742432"/>
-            <a:ext cx="2674620" cy="548640"/>
-          </a:xfrm>
-          <a:prstGeom prst="rect">
-            <a:avLst/>
-          </a:prstGeom>
-          <a:noFill/>
-        </p:spPr>
-        <p:txBody>
-          <a:bodyPr wrap="square">
-            <a:spAutoFit/>
-          </a:bodyPr>
-          <a:lstStyle/>
-          <a:p>
-            <a:pPr algn="l">
-              <a:lnSpc>
-                <a:spcPct val="115000"/>
-              </a:lnSpc>
-            </a:pPr>
-            <a:r>
-              <a:rPr sz="2200" b="1">
-                <a:solidFill>
-                  <a:srgbClr val="8AA6EF"/>
-                </a:solidFill>
-                <a:latin typeface="Consolas"/>
-              </a:rPr>
-              <a:t>+0.0000</a:t>
+              <a:t>were refuted by their own tests. Both are in the log, with the tables that killed them.</a:t>
             </a:r>
           </a:p>
         </p:txBody>

</xml_diff>